<commit_message>
chore(deck): add Darshan Gowda to Presenter/Participant names in PPTX and PDF
</commit_message>
<xml_diff>
--- a/SomnoCare_Pitch_Deck.pptx
+++ b/SomnoCare_Pitch_Deck.pptx
@@ -9888,7 +9888,7 @@
                 </a:solidFill>
                 <a:latin typeface="Arial"/>
               </a:rPr>
-              <a:t>Participant Name:</a:t>
+              <a:t>Participant / Presenter Names:</a:t>
             </a:r>
             <a:r>
               <a:rPr b="0" sz="1200">
@@ -9897,7 +9897,7 @@
                 </a:solidFill>
                 <a:latin typeface="Arial"/>
               </a:rPr>
-              <a:t> Bhuvanani Vattikonda</a:t>
+              <a:t> Bhuvanani Vattikonda &amp; Darshan Gowda</a:t>
             </a:r>
           </a:p>
           <a:p>

</xml_diff>